<commit_message>
docs: update generate_ppt.py and PPT for Vision multimodal architecture
슬라이드 6곳을 Vision 입력 흐름에 맞게 수정:
- 슬라이드 4 (전체 아키텍처): STEP 1 입력을 "회로도 이미지 (Vision 자동 분석)"으로 변경
- 슬라이드 8 (Phase 2 HW Agent): Vision 분석 항목 추가, 5개 구현 항목으로 확장
- 슬라이드 13 (모델 선택): Vision 행 추가 (Gemma 4 31B 공유 인스턴스)
- 슬라이드 14 (사용 가이드 개요): 준비 단계를 이미지/CSV 선택으로 변경, 입력 포맷을 이미지 우선으로 재구성
- 슬라이드 15 (사용 가이드 Step 1): 실행 순서 2번을 이미지 업로드로 변경, 제목 subtitle 업데이트
- 슬라이드 20 (UI 예시 Step 1): CSV 업로드 존 → 이미지 업로드 존 (Vision 표기)

Co-Authored-By: Claude Sonnet 4.6 <noreply@anthropic.com>
</commit_message>
<xml_diff>
--- a/STM32G4_Agent_Plan.pptx
+++ b/STM32G4_Agent_Plan.pptx
@@ -11238,7 +11238,7 @@
                   <a:srgbClr val="1B3A6B"/>
                 </a:solidFill>
               </a:rPr>
-              <a:t>Step 1</a:t>
+              <a:t>Vision</a:t>
             </a:r>
           </a:p>
         </p:txBody>
@@ -11272,8 +11272,8 @@
                   <a:srgbClr val="606060"/>
                 </a:solidFill>
               </a:rPr>
-              <a:t>HW 검증
-(추론)</a:t>
+              <a:t>회로도 이미지
+→ 핀맵 추출</a:t>
             </a:r>
           </a:p>
         </p:txBody>
@@ -11375,7 +11375,7 @@
                   <a:srgbClr val="107C10"/>
                 </a:solidFill>
               </a:rPr>
-              <a:t>~20GB</a:t>
+              <a:t>공유</a:t>
             </a:r>
           </a:p>
         </p:txBody>
@@ -11409,7 +11409,7 @@
                   <a:srgbClr val="606060"/>
                 </a:solidFill>
               </a:rPr>
-              <a:t>논리 추론 정확도 최상급, JSON 구조화 출력 우수</a:t>
+              <a:t>Step 1과 동일 인스턴스 재사용 — 이미지 → pinmap CSV + 초기 분석 생성</a:t>
             </a:r>
           </a:p>
         </p:txBody>
@@ -11486,7 +11486,7 @@
                   <a:srgbClr val="1B3A6B"/>
                 </a:solidFill>
               </a:rPr>
-              <a:t>Step 2</a:t>
+              <a:t>Step 1</a:t>
             </a:r>
           </a:p>
         </p:txBody>
@@ -11520,8 +11520,8 @@
                   <a:srgbClr val="606060"/>
                 </a:solidFill>
               </a:rPr>
-              <a:t>CubeMX
-자동화</a:t>
+              <a:t>HW 검증
+(추론)</a:t>
             </a:r>
           </a:p>
         </p:txBody>
@@ -11555,7 +11555,7 @@
                   <a:srgbClr val="2E6DB4"/>
                 </a:solidFill>
               </a:rPr>
-              <a:t>LLM 불필요</a:t>
+              <a:t>Gemma 4 31B Dense</a:t>
             </a:r>
           </a:p>
         </p:txBody>
@@ -11589,7 +11589,7 @@
                   <a:srgbClr val="1A1A1A"/>
                 </a:solidFill>
               </a:rPr>
-              <a:t>—</a:t>
+              <a:t>Q4_K_M</a:t>
             </a:r>
           </a:p>
         </p:txBody>
@@ -11623,7 +11623,7 @@
                   <a:srgbClr val="606060"/>
                 </a:solidFill>
               </a:rPr>
-              <a:t>0GB</a:t>
+              <a:t>~20GB</a:t>
             </a:r>
           </a:p>
         </p:txBody>
@@ -11657,7 +11657,7 @@
                   <a:srgbClr val="606060"/>
                 </a:solidFill>
               </a:rPr>
-              <a:t>결정론적 코드 생성 — CubeMX CLI 직접 사용</a:t>
+              <a:t>논리 추론 정확도 최상급, JSON 구조화 출력 우수 / Vision 분석 컨텍스트 포함</a:t>
             </a:r>
           </a:p>
         </p:txBody>
@@ -11734,7 +11734,7 @@
                   <a:srgbClr val="1B3A6B"/>
                 </a:solidFill>
               </a:rPr>
-              <a:t>Step 3</a:t>
+              <a:t>Step 2</a:t>
             </a:r>
           </a:p>
         </p:txBody>
@@ -11768,8 +11768,8 @@
                   <a:srgbClr val="606060"/>
                 </a:solidFill>
               </a:rPr>
-              <a:t>알고리즘
-통합</a:t>
+              <a:t>CubeMX
+자동화</a:t>
             </a:r>
           </a:p>
         </p:txBody>
@@ -11803,7 +11803,7 @@
                   <a:srgbClr val="2E6DB4"/>
                 </a:solidFill>
               </a:rPr>
-              <a:t>Gemma 4 26B MoE</a:t>
+              <a:t>LLM 불필요</a:t>
             </a:r>
           </a:p>
         </p:txBody>
@@ -11837,7 +11837,7 @@
                   <a:srgbClr val="1A1A1A"/>
                 </a:solidFill>
               </a:rPr>
-              <a:t>Q8</a:t>
+              <a:t>—</a:t>
             </a:r>
           </a:p>
         </p:txBody>
@@ -11871,7 +11871,7 @@
                   <a:srgbClr val="107C10"/>
                 </a:solidFill>
               </a:rPr>
-              <a:t>~22GB</a:t>
+              <a:t>0GB</a:t>
             </a:r>
           </a:p>
         </p:txBody>
@@ -11905,7 +11905,7 @@
                   <a:srgbClr val="606060"/>
                 </a:solidFill>
               </a:rPr>
-              <a:t>Active ~4B → 빠른 추론, USER CODE 삽입 최적화</a:t>
+              <a:t>결정론적 코드 생성 — CubeMX CLI 직접 사용</a:t>
             </a:r>
           </a:p>
         </p:txBody>
@@ -11982,7 +11982,7 @@
                   <a:srgbClr val="1B3A6B"/>
                 </a:solidFill>
               </a:rPr>
-              <a:t>임베딩</a:t>
+              <a:t>Step 3</a:t>
             </a:r>
           </a:p>
         </p:txBody>
@@ -12016,7 +12016,8 @@
                   <a:srgbClr val="606060"/>
                 </a:solidFill>
               </a:rPr>
-              <a:t>RAG 검색</a:t>
+              <a:t>알고리즘
+통합</a:t>
             </a:r>
           </a:p>
         </p:txBody>
@@ -12050,7 +12051,7 @@
                   <a:srgbClr val="2E6DB4"/>
                 </a:solidFill>
               </a:rPr>
-              <a:t>BAAI/bge-m3</a:t>
+              <a:t>Gemma 4 26B MoE</a:t>
             </a:r>
           </a:p>
         </p:txBody>
@@ -12084,7 +12085,7 @@
                   <a:srgbClr val="1A1A1A"/>
                 </a:solidFill>
               </a:rPr>
-              <a:t>FP32</a:t>
+              <a:t>Q8</a:t>
             </a:r>
           </a:p>
         </p:txBody>
@@ -12118,7 +12119,7 @@
                   <a:srgbClr val="107C10"/>
                 </a:solidFill>
               </a:rPr>
-              <a:t>~2GB</a:t>
+              <a:t>~22GB</a:t>
             </a:r>
           </a:p>
         </p:txBody>
@@ -12152,6 +12153,253 @@
                   <a:srgbClr val="606060"/>
                 </a:solidFill>
               </a:rPr>
+              <a:t>Active ~4B → 빠른 추론, USER CODE 삽입 최적화</a:t>
+            </a:r>
+          </a:p>
+        </p:txBody>
+      </p:sp>
+      <p:sp>
+        <p:nvSpPr>
+          <p:cNvPr id="44" name="Rectangle 43"/>
+          <p:cNvSpPr/>
+          <p:nvPr/>
+        </p:nvSpPr>
+        <p:spPr>
+          <a:xfrm>
+            <a:off x="365760" y="4178808"/>
+            <a:ext cx="11430000" cy="594360"/>
+          </a:xfrm>
+          <a:prstGeom prst="rect">
+            <a:avLst/>
+          </a:prstGeom>
+          <a:solidFill>
+            <a:srgbClr val="D6E8FF"/>
+          </a:solidFill>
+          <a:ln>
+            <a:noFill/>
+          </a:ln>
+        </p:spPr>
+        <p:style>
+          <a:lnRef idx="1">
+            <a:schemeClr val="accent1"/>
+          </a:lnRef>
+          <a:fillRef idx="3">
+            <a:schemeClr val="accent1"/>
+          </a:fillRef>
+          <a:effectRef idx="2">
+            <a:schemeClr val="accent1"/>
+          </a:effectRef>
+          <a:fontRef idx="minor">
+            <a:schemeClr val="lt1"/>
+          </a:fontRef>
+        </p:style>
+        <p:txBody>
+          <a:bodyPr rtlCol="0" anchor="ctr"/>
+          <a:lstStyle/>
+          <a:p>
+            <a:pPr algn="ctr"/>
+          </a:p>
+        </p:txBody>
+      </p:sp>
+      <p:sp>
+        <p:nvSpPr>
+          <p:cNvPr id="45" name="TextBox 44"/>
+          <p:cNvSpPr txBox="1"/>
+          <p:nvPr/>
+        </p:nvSpPr>
+        <p:spPr>
+          <a:xfrm>
+            <a:off x="457200" y="4224528"/>
+            <a:ext cx="822960" cy="502920"/>
+          </a:xfrm>
+          <a:prstGeom prst="rect">
+            <a:avLst/>
+          </a:prstGeom>
+          <a:noFill/>
+        </p:spPr>
+        <p:txBody>
+          <a:bodyPr wrap="square">
+            <a:spAutoFit/>
+          </a:bodyPr>
+          <a:lstStyle/>
+          <a:p>
+            <a:pPr algn="l"/>
+            <a:r>
+              <a:rPr sz="1250" b="1" i="0">
+                <a:solidFill>
+                  <a:srgbClr val="1B3A6B"/>
+                </a:solidFill>
+              </a:rPr>
+              <a:t>임베딩</a:t>
+            </a:r>
+          </a:p>
+        </p:txBody>
+      </p:sp>
+      <p:sp>
+        <p:nvSpPr>
+          <p:cNvPr id="46" name="TextBox 45"/>
+          <p:cNvSpPr txBox="1"/>
+          <p:nvPr/>
+        </p:nvSpPr>
+        <p:spPr>
+          <a:xfrm>
+            <a:off x="1280160" y="4224528"/>
+            <a:ext cx="1371600" cy="502920"/>
+          </a:xfrm>
+          <a:prstGeom prst="rect">
+            <a:avLst/>
+          </a:prstGeom>
+          <a:noFill/>
+        </p:spPr>
+        <p:txBody>
+          <a:bodyPr wrap="square">
+            <a:spAutoFit/>
+          </a:bodyPr>
+          <a:lstStyle/>
+          <a:p>
+            <a:pPr algn="l"/>
+            <a:r>
+              <a:rPr sz="1150" b="0" i="0">
+                <a:solidFill>
+                  <a:srgbClr val="606060"/>
+                </a:solidFill>
+              </a:rPr>
+              <a:t>RAG 검색</a:t>
+            </a:r>
+          </a:p>
+        </p:txBody>
+      </p:sp>
+      <p:sp>
+        <p:nvSpPr>
+          <p:cNvPr id="47" name="TextBox 46"/>
+          <p:cNvSpPr txBox="1"/>
+          <p:nvPr/>
+        </p:nvSpPr>
+        <p:spPr>
+          <a:xfrm>
+            <a:off x="2697480" y="4224528"/>
+            <a:ext cx="2560320" cy="502920"/>
+          </a:xfrm>
+          <a:prstGeom prst="rect">
+            <a:avLst/>
+          </a:prstGeom>
+          <a:noFill/>
+        </p:spPr>
+        <p:txBody>
+          <a:bodyPr wrap="square">
+            <a:spAutoFit/>
+          </a:bodyPr>
+          <a:lstStyle/>
+          <a:p>
+            <a:pPr algn="l"/>
+            <a:r>
+              <a:rPr sz="1150" b="1" i="0">
+                <a:solidFill>
+                  <a:srgbClr val="2E6DB4"/>
+                </a:solidFill>
+              </a:rPr>
+              <a:t>BAAI/bge-m3</a:t>
+            </a:r>
+          </a:p>
+        </p:txBody>
+      </p:sp>
+      <p:sp>
+        <p:nvSpPr>
+          <p:cNvPr id="48" name="TextBox 47"/>
+          <p:cNvSpPr txBox="1"/>
+          <p:nvPr/>
+        </p:nvSpPr>
+        <p:spPr>
+          <a:xfrm>
+            <a:off x="5303520" y="4224528"/>
+            <a:ext cx="822960" cy="502920"/>
+          </a:xfrm>
+          <a:prstGeom prst="rect">
+            <a:avLst/>
+          </a:prstGeom>
+          <a:noFill/>
+        </p:spPr>
+        <p:txBody>
+          <a:bodyPr wrap="square">
+            <a:spAutoFit/>
+          </a:bodyPr>
+          <a:lstStyle/>
+          <a:p>
+            <a:pPr algn="ctr"/>
+            <a:r>
+              <a:rPr sz="1150" b="0" i="0">
+                <a:solidFill>
+                  <a:srgbClr val="1A1A1A"/>
+                </a:solidFill>
+              </a:rPr>
+              <a:t>FP32</a:t>
+            </a:r>
+          </a:p>
+        </p:txBody>
+      </p:sp>
+      <p:sp>
+        <p:nvSpPr>
+          <p:cNvPr id="49" name="TextBox 48"/>
+          <p:cNvSpPr txBox="1"/>
+          <p:nvPr/>
+        </p:nvSpPr>
+        <p:spPr>
+          <a:xfrm>
+            <a:off x="6172200" y="4224528"/>
+            <a:ext cx="822960" cy="502920"/>
+          </a:xfrm>
+          <a:prstGeom prst="rect">
+            <a:avLst/>
+          </a:prstGeom>
+          <a:noFill/>
+        </p:spPr>
+        <p:txBody>
+          <a:bodyPr wrap="square">
+            <a:spAutoFit/>
+          </a:bodyPr>
+          <a:lstStyle/>
+          <a:p>
+            <a:pPr algn="ctr"/>
+            <a:r>
+              <a:rPr sz="1200" b="1" i="0">
+                <a:solidFill>
+                  <a:srgbClr val="107C10"/>
+                </a:solidFill>
+              </a:rPr>
+              <a:t>~2GB</a:t>
+            </a:r>
+          </a:p>
+        </p:txBody>
+      </p:sp>
+      <p:sp>
+        <p:nvSpPr>
+          <p:cNvPr id="50" name="TextBox 49"/>
+          <p:cNvSpPr txBox="1"/>
+          <p:nvPr/>
+        </p:nvSpPr>
+        <p:spPr>
+          <a:xfrm>
+            <a:off x="7086600" y="4224528"/>
+            <a:ext cx="4480560" cy="502920"/>
+          </a:xfrm>
+          <a:prstGeom prst="rect">
+            <a:avLst/>
+          </a:prstGeom>
+          <a:noFill/>
+        </p:spPr>
+        <p:txBody>
+          <a:bodyPr wrap="square">
+            <a:spAutoFit/>
+          </a:bodyPr>
+          <a:lstStyle/>
+          <a:p>
+            <a:pPr algn="l"/>
+            <a:r>
+              <a:rPr sz="1100" b="0" i="0">
+                <a:solidFill>
+                  <a:srgbClr val="606060"/>
+                </a:solidFill>
+              </a:rPr>
               <a:t>한국어+영어 혼재 문서 최적, 로컬 실행 가능</a:t>
             </a:r>
           </a:p>
@@ -12159,7 +12407,7 @@
       </p:sp>
       <p:sp>
         <p:nvSpPr>
-          <p:cNvPr id="44" name="TextBox 43"/>
+          <p:cNvPr id="51" name="TextBox 50"/>
           <p:cNvSpPr txBox="1"/>
           <p:nvPr/>
         </p:nvSpPr>
@@ -12193,7 +12441,7 @@
       </p:sp>
       <p:sp>
         <p:nvSpPr>
-          <p:cNvPr id="45" name="Rectangle 44"/>
+          <p:cNvPr id="52" name="Rectangle 51"/>
           <p:cNvSpPr/>
           <p:nvPr/>
         </p:nvSpPr>
@@ -12236,7 +12484,7 @@
       </p:sp>
       <p:sp>
         <p:nvSpPr>
-          <p:cNvPr id="46" name="TextBox 45"/>
+          <p:cNvPr id="53" name="TextBox 52"/>
           <p:cNvSpPr txBox="1"/>
           <p:nvPr/>
         </p:nvSpPr>
@@ -12270,7 +12518,7 @@
       </p:sp>
       <p:sp>
         <p:nvSpPr>
-          <p:cNvPr id="47" name="TextBox 46"/>
+          <p:cNvPr id="54" name="TextBox 53"/>
           <p:cNvSpPr txBox="1"/>
           <p:nvPr/>
         </p:nvSpPr>
@@ -12304,7 +12552,7 @@
       </p:sp>
       <p:sp>
         <p:nvSpPr>
-          <p:cNvPr id="48" name="TextBox 47"/>
+          <p:cNvPr id="55" name="TextBox 54"/>
           <p:cNvSpPr txBox="1"/>
           <p:nvPr/>
         </p:nvSpPr>
@@ -12338,7 +12586,7 @@
       </p:sp>
       <p:sp>
         <p:nvSpPr>
-          <p:cNvPr id="49" name="TextBox 48"/>
+          <p:cNvPr id="56" name="TextBox 55"/>
           <p:cNvSpPr txBox="1"/>
           <p:nvPr/>
         </p:nvSpPr>
@@ -12372,7 +12620,7 @@
       </p:sp>
       <p:sp>
         <p:nvSpPr>
-          <p:cNvPr id="50" name="TextBox 49"/>
+          <p:cNvPr id="57" name="TextBox 56"/>
           <p:cNvSpPr txBox="1"/>
           <p:nvPr/>
         </p:nvSpPr>
@@ -12406,7 +12654,7 @@
       </p:sp>
       <p:sp>
         <p:nvSpPr>
-          <p:cNvPr id="51" name="Rectangle 50"/>
+          <p:cNvPr id="58" name="Rectangle 57"/>
           <p:cNvSpPr/>
           <p:nvPr/>
         </p:nvSpPr>
@@ -12449,7 +12697,7 @@
       </p:sp>
       <p:sp>
         <p:nvSpPr>
-          <p:cNvPr id="52" name="TextBox 51"/>
+          <p:cNvPr id="59" name="TextBox 58"/>
           <p:cNvSpPr txBox="1"/>
           <p:nvPr/>
         </p:nvSpPr>
@@ -12483,7 +12731,7 @@
       </p:sp>
       <p:sp>
         <p:nvSpPr>
-          <p:cNvPr id="53" name="TextBox 52"/>
+          <p:cNvPr id="60" name="TextBox 59"/>
           <p:cNvSpPr txBox="1"/>
           <p:nvPr/>
         </p:nvSpPr>
@@ -12517,7 +12765,7 @@
       </p:sp>
       <p:sp>
         <p:nvSpPr>
-          <p:cNvPr id="54" name="TextBox 53"/>
+          <p:cNvPr id="61" name="TextBox 60"/>
           <p:cNvSpPr txBox="1"/>
           <p:nvPr/>
         </p:nvSpPr>
@@ -12551,7 +12799,7 @@
       </p:sp>
       <p:sp>
         <p:nvSpPr>
-          <p:cNvPr id="55" name="TextBox 54"/>
+          <p:cNvPr id="62" name="TextBox 61"/>
           <p:cNvSpPr txBox="1"/>
           <p:nvPr/>
         </p:nvSpPr>
@@ -12585,7 +12833,7 @@
       </p:sp>
       <p:sp>
         <p:nvSpPr>
-          <p:cNvPr id="56" name="TextBox 55"/>
+          <p:cNvPr id="63" name="TextBox 62"/>
           <p:cNvSpPr txBox="1"/>
           <p:nvPr/>
         </p:nvSpPr>
@@ -12619,7 +12867,7 @@
       </p:sp>
       <p:sp>
         <p:nvSpPr>
-          <p:cNvPr id="57" name="Rectangle 56"/>
+          <p:cNvPr id="64" name="Rectangle 63"/>
           <p:cNvSpPr/>
           <p:nvPr/>
         </p:nvSpPr>
@@ -12662,7 +12910,7 @@
       </p:sp>
       <p:sp>
         <p:nvSpPr>
-          <p:cNvPr id="58" name="TextBox 57"/>
+          <p:cNvPr id="65" name="TextBox 64"/>
           <p:cNvSpPr txBox="1"/>
           <p:nvPr/>
         </p:nvSpPr>
@@ -12696,7 +12944,7 @@
       </p:sp>
       <p:sp>
         <p:nvSpPr>
-          <p:cNvPr id="59" name="TextBox 58"/>
+          <p:cNvPr id="66" name="TextBox 65"/>
           <p:cNvSpPr txBox="1"/>
           <p:nvPr/>
         </p:nvSpPr>
@@ -12730,7 +12978,7 @@
       </p:sp>
       <p:sp>
         <p:nvSpPr>
-          <p:cNvPr id="60" name="TextBox 59"/>
+          <p:cNvPr id="67" name="TextBox 66"/>
           <p:cNvSpPr txBox="1"/>
           <p:nvPr/>
         </p:nvSpPr>
@@ -12764,7 +13012,7 @@
       </p:sp>
       <p:sp>
         <p:nvSpPr>
-          <p:cNvPr id="61" name="TextBox 60"/>
+          <p:cNvPr id="68" name="TextBox 67"/>
           <p:cNvSpPr txBox="1"/>
           <p:nvPr/>
         </p:nvSpPr>
@@ -12798,7 +13046,7 @@
       </p:sp>
       <p:sp>
         <p:nvSpPr>
-          <p:cNvPr id="62" name="TextBox 61"/>
+          <p:cNvPr id="69" name="TextBox 68"/>
           <p:cNvSpPr txBox="1"/>
           <p:nvPr/>
         </p:nvSpPr>
@@ -12832,7 +13080,7 @@
       </p:sp>
       <p:sp>
         <p:nvSpPr>
-          <p:cNvPr id="63" name="Rectangle 62"/>
+          <p:cNvPr id="70" name="Rectangle 69"/>
           <p:cNvSpPr/>
           <p:nvPr/>
         </p:nvSpPr>
@@ -12875,7 +13123,7 @@
       </p:sp>
       <p:sp>
         <p:nvSpPr>
-          <p:cNvPr id="64" name="TextBox 63"/>
+          <p:cNvPr id="71" name="TextBox 70"/>
           <p:cNvSpPr txBox="1"/>
           <p:nvPr/>
         </p:nvSpPr>
@@ -12909,7 +13157,7 @@
       </p:sp>
       <p:sp>
         <p:nvSpPr>
-          <p:cNvPr id="65" name="TextBox 64"/>
+          <p:cNvPr id="72" name="TextBox 71"/>
           <p:cNvSpPr txBox="1"/>
           <p:nvPr/>
         </p:nvSpPr>
@@ -12943,7 +13191,7 @@
       </p:sp>
       <p:sp>
         <p:nvSpPr>
-          <p:cNvPr id="66" name="TextBox 65"/>
+          <p:cNvPr id="73" name="TextBox 72"/>
           <p:cNvSpPr txBox="1"/>
           <p:nvPr/>
         </p:nvSpPr>
@@ -12977,7 +13225,7 @@
       </p:sp>
       <p:sp>
         <p:nvSpPr>
-          <p:cNvPr id="67" name="TextBox 66"/>
+          <p:cNvPr id="74" name="TextBox 73"/>
           <p:cNvSpPr txBox="1"/>
           <p:nvPr/>
         </p:nvSpPr>
@@ -13011,7 +13259,7 @@
       </p:sp>
       <p:sp>
         <p:nvSpPr>
-          <p:cNvPr id="68" name="TextBox 67"/>
+          <p:cNvPr id="75" name="TextBox 74"/>
           <p:cNvSpPr txBox="1"/>
           <p:nvPr/>
         </p:nvSpPr>
@@ -13045,7 +13293,7 @@
       </p:sp>
       <p:sp>
         <p:nvSpPr>
-          <p:cNvPr id="69" name="TextBox 68"/>
+          <p:cNvPr id="76" name="TextBox 75"/>
           <p:cNvSpPr txBox="1"/>
           <p:nvPr/>
         </p:nvSpPr>
@@ -13079,7 +13327,7 @@
       </p:sp>
       <p:sp>
         <p:nvSpPr>
-          <p:cNvPr id="70" name="Rectangle 69"/>
+          <p:cNvPr id="77" name="Rectangle 76"/>
           <p:cNvSpPr/>
           <p:nvPr/>
         </p:nvSpPr>
@@ -13122,7 +13370,7 @@
       </p:sp>
       <p:sp>
         <p:nvSpPr>
-          <p:cNvPr id="71" name="TextBox 70"/>
+          <p:cNvPr id="78" name="TextBox 77"/>
           <p:cNvSpPr txBox="1"/>
           <p:nvPr/>
         </p:nvSpPr>
@@ -13156,7 +13404,7 @@
       </p:sp>
       <p:sp>
         <p:nvSpPr>
-          <p:cNvPr id="72" name="TextBox 71"/>
+          <p:cNvPr id="79" name="TextBox 78"/>
           <p:cNvSpPr txBox="1"/>
           <p:nvPr/>
         </p:nvSpPr>
@@ -13190,7 +13438,7 @@
       </p:sp>
       <p:sp>
         <p:nvSpPr>
-          <p:cNvPr id="73" name="Rectangle 72"/>
+          <p:cNvPr id="80" name="Rectangle 79"/>
           <p:cNvSpPr/>
           <p:nvPr/>
         </p:nvSpPr>
@@ -13233,7 +13481,7 @@
       </p:sp>
       <p:sp>
         <p:nvSpPr>
-          <p:cNvPr id="74" name="TextBox 73"/>
+          <p:cNvPr id="81" name="TextBox 80"/>
           <p:cNvSpPr txBox="1"/>
           <p:nvPr/>
         </p:nvSpPr>
@@ -13267,7 +13515,7 @@
       </p:sp>
       <p:sp>
         <p:nvSpPr>
-          <p:cNvPr id="75" name="TextBox 74"/>
+          <p:cNvPr id="82" name="TextBox 81"/>
           <p:cNvSpPr txBox="1"/>
           <p:nvPr/>
         </p:nvSpPr>
@@ -13301,7 +13549,7 @@
       </p:sp>
       <p:sp>
         <p:nvSpPr>
-          <p:cNvPr id="76" name="Rectangle 75"/>
+          <p:cNvPr id="83" name="Rectangle 82"/>
           <p:cNvSpPr/>
           <p:nvPr/>
         </p:nvSpPr>
@@ -13344,7 +13592,7 @@
       </p:sp>
       <p:sp>
         <p:nvSpPr>
-          <p:cNvPr id="77" name="TextBox 76"/>
+          <p:cNvPr id="84" name="TextBox 83"/>
           <p:cNvSpPr txBox="1"/>
           <p:nvPr/>
         </p:nvSpPr>
@@ -13842,8 +14090,8 @@
                   <a:srgbClr val="1A1A1A"/>
                 </a:solidFill>
               </a:rPr>
-              <a:t>회로도 핀맵
-작성 (CSV)</a:t>
+              <a:t>회로도 이미지
+또는 CSV 준비</a:t>
             </a:r>
           </a:p>
         </p:txBody>
@@ -14032,7 +14280,7 @@
                 </a:solidFill>
               </a:rPr>
               <a:t>Step 1 Agent
-실행</a:t>
+(Vision + 검증)</a:t>
             </a:r>
           </a:p>
         </p:txBody>
@@ -15054,7 +15302,7 @@
                   <a:srgbClr val="107C10"/>
                 </a:solidFill>
               </a:rPr>
-              <a:t>입력 파일 포맷 (CSV 예시)</a:t>
+              <a:t>입력 방식 (권장: 회로도 이미지)</a:t>
             </a:r>
           </a:p>
         </p:txBody>
@@ -15068,7 +15316,7 @@
         <p:spPr>
           <a:xfrm>
             <a:off x="365760" y="3401568"/>
-            <a:ext cx="5303520" cy="3063240"/>
+            <a:ext cx="5303520" cy="1005840"/>
           </a:xfrm>
           <a:prstGeom prst="rect">
             <a:avLst/>
@@ -15104,54 +15352,268 @@
       </p:sp>
       <p:sp>
         <p:nvSpPr>
-          <p:cNvPr id="47" name="TextBox 46"/>
-          <p:cNvSpPr txBox="1"/>
-          <p:nvPr/>
-        </p:nvSpPr>
-        <p:spPr>
-          <a:xfrm>
-            <a:off x="502920" y="3447288"/>
-            <a:ext cx="5120640" cy="2971800"/>
-          </a:xfrm>
-          <a:prstGeom prst="rect">
-            <a:avLst/>
-          </a:prstGeom>
-          <a:noFill/>
-        </p:spPr>
-        <p:txBody>
-          <a:bodyPr wrap="square">
-            <a:spAutoFit/>
-          </a:bodyPr>
-          <a:lstStyle/>
-          <a:p>
-            <a:pPr algn="l"/>
-            <a:r>
-              <a:rPr sz="1100" b="0" i="0">
+          <p:cNvPr id="47" name="Rectangle 46"/>
+          <p:cNvSpPr/>
+          <p:nvPr/>
+        </p:nvSpPr>
+        <p:spPr>
+          <a:xfrm>
+            <a:off x="365760" y="3401568"/>
+            <a:ext cx="5303520" cy="1005840"/>
+          </a:xfrm>
+          <a:prstGeom prst="rect">
+            <a:avLst/>
+          </a:prstGeom>
+          <a:noFill/>
+          <a:ln w="19050">
+            <a:solidFill>
+              <a:srgbClr val="007A8A"/>
+            </a:solidFill>
+          </a:ln>
+        </p:spPr>
+        <p:style>
+          <a:lnRef idx="1">
+            <a:schemeClr val="accent1"/>
+          </a:lnRef>
+          <a:fillRef idx="3">
+            <a:schemeClr val="accent1"/>
+          </a:fillRef>
+          <a:effectRef idx="2">
+            <a:schemeClr val="accent1"/>
+          </a:effectRef>
+          <a:fontRef idx="minor">
+            <a:schemeClr val="lt1"/>
+          </a:fontRef>
+        </p:style>
+        <p:txBody>
+          <a:bodyPr rtlCol="0" anchor="ctr"/>
+          <a:lstStyle/>
+          <a:p>
+            <a:pPr algn="ctr"/>
+          </a:p>
+        </p:txBody>
+      </p:sp>
+      <p:sp>
+        <p:nvSpPr>
+          <p:cNvPr id="48" name="TextBox 47"/>
+          <p:cNvSpPr txBox="1"/>
+          <p:nvPr/>
+        </p:nvSpPr>
+        <p:spPr>
+          <a:xfrm>
+            <a:off x="502920" y="3438144"/>
+            <a:ext cx="5120640" cy="256032"/>
+          </a:xfrm>
+          <a:prstGeom prst="rect">
+            <a:avLst/>
+          </a:prstGeom>
+          <a:noFill/>
+        </p:spPr>
+        <p:txBody>
+          <a:bodyPr wrap="square">
+            <a:spAutoFit/>
+          </a:bodyPr>
+          <a:lstStyle/>
+          <a:p>
+            <a:pPr algn="l"/>
+            <a:r>
+              <a:rPr sz="1050" b="1" i="0">
+                <a:solidFill>
+                  <a:srgbClr val="007A8A"/>
+                </a:solidFill>
+              </a:rPr>
+              <a:t>방법 1 — 회로도 이미지 업로드 (JPEG/PNG)</a:t>
+            </a:r>
+          </a:p>
+        </p:txBody>
+      </p:sp>
+      <p:sp>
+        <p:nvSpPr>
+          <p:cNvPr id="49" name="TextBox 48"/>
+          <p:cNvSpPr txBox="1"/>
+          <p:nvPr/>
+        </p:nvSpPr>
+        <p:spPr>
+          <a:xfrm>
+            <a:off x="502920" y="3703320"/>
+            <a:ext cx="5120640" cy="228600"/>
+          </a:xfrm>
+          <a:prstGeom prst="rect">
+            <a:avLst/>
+          </a:prstGeom>
+          <a:noFill/>
+        </p:spPr>
+        <p:txBody>
+          <a:bodyPr wrap="square">
+            <a:spAutoFit/>
+          </a:bodyPr>
+          <a:lstStyle/>
+          <a:p>
+            <a:pPr algn="l"/>
+            <a:r>
+              <a:rPr sz="1000" b="0" i="0">
                 <a:solidFill>
                   <a:srgbClr val="CEF5B0"/>
                 </a:solidFill>
               </a:rPr>
-              <a:t>chip,STM32G474RET6
-hse_mhz,24
-sysclk_mhz,170
-pin,function,label
-PA8,TIM1_CH1,PWM_UH
-PA7,TIM1_CH1N,PWM_UL
-PA9,TIM1_CH2,PWM_VH
-PB0,TIM1_CH2N,PWM_VL
-PA10,TIM1_CH3,PWM_WH
-PB1,TIM1_CH3N,PWM_WL
-PA0,TIM2_CH1,ENC_A
-PA1,TIM2_CH2,ENC_B
-PB8,FDCAN1_RX,CAN_RX
-PB9,FDCAN1_TX,CAN_TX</a:t>
-            </a:r>
-          </a:p>
-        </p:txBody>
-      </p:sp>
-      <p:sp>
-        <p:nvSpPr>
-          <p:cNvPr id="48" name="TextBox 47"/>
+              <a:t>Gemma 4 31B Vision이 핀맵을 자동 추출 → 사용자 CSV 작성 불필요</a:t>
+            </a:r>
+          </a:p>
+        </p:txBody>
+      </p:sp>
+      <p:sp>
+        <p:nvSpPr>
+          <p:cNvPr id="50" name="TextBox 49"/>
+          <p:cNvSpPr txBox="1"/>
+          <p:nvPr/>
+        </p:nvSpPr>
+        <p:spPr>
+          <a:xfrm>
+            <a:off x="502920" y="3959352"/>
+            <a:ext cx="5120640" cy="228600"/>
+          </a:xfrm>
+          <a:prstGeom prst="rect">
+            <a:avLst/>
+          </a:prstGeom>
+          <a:noFill/>
+        </p:spPr>
+        <p:txBody>
+          <a:bodyPr wrap="square">
+            <a:spAutoFit/>
+          </a:bodyPr>
+          <a:lstStyle/>
+          <a:p>
+            <a:pPr algn="l"/>
+            <a:r>
+              <a:rPr sz="950" b="0" i="1">
+                <a:solidFill>
+                  <a:srgbClr val="90D090"/>
+                </a:solidFill>
+              </a:rPr>
+              <a:t>schematic_v3.png  (드래그 or 클릭 업로드)</a:t>
+            </a:r>
+          </a:p>
+        </p:txBody>
+      </p:sp>
+      <p:sp>
+        <p:nvSpPr>
+          <p:cNvPr id="51" name="Rectangle 50"/>
+          <p:cNvSpPr/>
+          <p:nvPr/>
+        </p:nvSpPr>
+        <p:spPr>
+          <a:xfrm>
+            <a:off x="365760" y="4480560"/>
+            <a:ext cx="5303520" cy="1984248"/>
+          </a:xfrm>
+          <a:prstGeom prst="rect">
+            <a:avLst/>
+          </a:prstGeom>
+          <a:solidFill>
+            <a:srgbClr val="1E1E1E"/>
+          </a:solidFill>
+          <a:ln>
+            <a:noFill/>
+          </a:ln>
+        </p:spPr>
+        <p:style>
+          <a:lnRef idx="1">
+            <a:schemeClr val="accent1"/>
+          </a:lnRef>
+          <a:fillRef idx="3">
+            <a:schemeClr val="accent1"/>
+          </a:fillRef>
+          <a:effectRef idx="2">
+            <a:schemeClr val="accent1"/>
+          </a:effectRef>
+          <a:fontRef idx="minor">
+            <a:schemeClr val="lt1"/>
+          </a:fontRef>
+        </p:style>
+        <p:txBody>
+          <a:bodyPr rtlCol="0" anchor="ctr"/>
+          <a:lstStyle/>
+          <a:p>
+            <a:pPr algn="ctr"/>
+          </a:p>
+        </p:txBody>
+      </p:sp>
+      <p:sp>
+        <p:nvSpPr>
+          <p:cNvPr id="52" name="TextBox 51"/>
+          <p:cNvSpPr txBox="1"/>
+          <p:nvPr/>
+        </p:nvSpPr>
+        <p:spPr>
+          <a:xfrm>
+            <a:off x="502920" y="4507992"/>
+            <a:ext cx="5120640" cy="256032"/>
+          </a:xfrm>
+          <a:prstGeom prst="rect">
+            <a:avLst/>
+          </a:prstGeom>
+          <a:noFill/>
+        </p:spPr>
+        <p:txBody>
+          <a:bodyPr wrap="square">
+            <a:spAutoFit/>
+          </a:bodyPr>
+          <a:lstStyle/>
+          <a:p>
+            <a:pPr algn="l"/>
+            <a:r>
+              <a:rPr sz="1050" b="1" i="0">
+                <a:solidFill>
+                  <a:srgbClr val="AAAAAA"/>
+                </a:solidFill>
+              </a:rPr>
+              <a:t>방법 2 — CSV 직접 입력 (이미지 없을 때)</a:t>
+            </a:r>
+          </a:p>
+        </p:txBody>
+      </p:sp>
+      <p:sp>
+        <p:nvSpPr>
+          <p:cNvPr id="53" name="TextBox 52"/>
+          <p:cNvSpPr txBox="1"/>
+          <p:nvPr/>
+        </p:nvSpPr>
+        <p:spPr>
+          <a:xfrm>
+            <a:off x="502920" y="4773168"/>
+            <a:ext cx="5120640" cy="1627632"/>
+          </a:xfrm>
+          <a:prstGeom prst="rect">
+            <a:avLst/>
+          </a:prstGeom>
+          <a:noFill/>
+        </p:spPr>
+        <p:txBody>
+          <a:bodyPr wrap="square">
+            <a:spAutoFit/>
+          </a:bodyPr>
+          <a:lstStyle/>
+          <a:p>
+            <a:pPr algn="l"/>
+            <a:r>
+              <a:rPr sz="1050" b="0" i="0">
+                <a:solidFill>
+                  <a:srgbClr val="CEF5B0"/>
+                </a:solidFill>
+              </a:rPr>
+              <a:t>chip,pin,function,label
+STM32G474RET6,PA8,TIM1_CH1,PWM_UH
+STM32G474RET6,PA7,TIM1_CH1N,PWM_UL
+STM32G474RET6,PB8,FDCAN1_RX,CAN_RX
+STM32G474RET6,PB9,FDCAN1_TX,CAN_TX
+...  (전체 핀 목록)</a:t>
+            </a:r>
+          </a:p>
+        </p:txBody>
+      </p:sp>
+      <p:sp>
+        <p:nvSpPr>
+          <p:cNvPr id="54" name="TextBox 53"/>
           <p:cNvSpPr txBox="1"/>
           <p:nvPr/>
         </p:nvSpPr>
@@ -15185,7 +15647,7 @@
       </p:sp>
       <p:sp>
         <p:nvSpPr>
-          <p:cNvPr id="49" name="TextBox 48"/>
+          <p:cNvPr id="55" name="TextBox 54"/>
           <p:cNvSpPr txBox="1"/>
           <p:nvPr/>
         </p:nvSpPr>
@@ -15219,7 +15681,7 @@
       </p:sp>
       <p:sp>
         <p:nvSpPr>
-          <p:cNvPr id="50" name="Rectangle 49"/>
+          <p:cNvPr id="56" name="Rectangle 55"/>
           <p:cNvSpPr/>
           <p:nvPr/>
         </p:nvSpPr>
@@ -15262,7 +15724,7 @@
       </p:sp>
       <p:sp>
         <p:nvSpPr>
-          <p:cNvPr id="51" name="Rectangle 50"/>
+          <p:cNvPr id="57" name="Rectangle 56"/>
           <p:cNvSpPr/>
           <p:nvPr/>
         </p:nvSpPr>
@@ -15305,7 +15767,7 @@
       </p:sp>
       <p:sp>
         <p:nvSpPr>
-          <p:cNvPr id="52" name="TextBox 51"/>
+          <p:cNvPr id="58" name="TextBox 57"/>
           <p:cNvSpPr txBox="1"/>
           <p:nvPr/>
         </p:nvSpPr>
@@ -15347,7 +15809,7 @@
       </p:sp>
       <p:sp>
         <p:nvSpPr>
-          <p:cNvPr id="53" name="Rectangle 52"/>
+          <p:cNvPr id="59" name="Rectangle 58"/>
           <p:cNvSpPr/>
           <p:nvPr/>
         </p:nvSpPr>
@@ -15390,7 +15852,7 @@
       </p:sp>
       <p:sp>
         <p:nvSpPr>
-          <p:cNvPr id="54" name="TextBox 53"/>
+          <p:cNvPr id="60" name="TextBox 59"/>
           <p:cNvSpPr txBox="1"/>
           <p:nvPr/>
         </p:nvSpPr>
@@ -15589,7 +16051,7 @@
                   <a:srgbClr val="FFFFFF"/>
                 </a:solidFill>
               </a:rPr>
-              <a:t>회로도 핀맵 CSV + 자연어 프롬프트 입력 → LLM 파싱 → 검증 리포트</a:t>
+              <a:t>회로도 이미지 + 자연어 프롬프트 → Vision 분석 → Rule Engine + RAG + LLM → 검증 리포트</a:t>
             </a:r>
           </a:p>
         </p:txBody>
@@ -15965,7 +16427,7 @@
                   <a:srgbClr val="1A1A1A"/>
                 </a:solidFill>
               </a:rPr>
-              <a:t>2.  핀맵 CSV 파일 업로드 (회로도에서 추출)</a:t>
+              <a:t>2.  회로도 이미지 업로드 (JPEG/PNG — Vision이 핀맵 자동 추출)</a:t>
             </a:r>
           </a:p>
         </p:txBody>
@@ -16119,7 +16581,7 @@
                   <a:srgbClr val="1A1A1A"/>
                 </a:solidFill>
               </a:rPr>
-              <a:t>4.  [핀 검증 실행] 버튼 클릭</a:t>
+              <a:t>4.  [검증 실행] 버튼 클릭</a:t>
             </a:r>
           </a:p>
         </p:txBody>
@@ -16196,7 +16658,7 @@
                   <a:srgbClr val="1A1A1A"/>
                 </a:solidFill>
               </a:rPr>
-              <a:t>5.  검증 결과 리포트 확인 (PASS / FAIL)</a:t>
+              <a:t>5.  Vision 분석 결과 확인 → 검증 리포트 확인 (PASS / FAIL)</a:t>
             </a:r>
           </a:p>
         </p:txBody>
@@ -28087,7 +28549,7 @@
                   <a:srgbClr val="FFFFFF"/>
                 </a:solidFill>
               </a:rPr>
-              <a:t>CSV 업로드 + 요구사항 JSON 입력 → 검증 결과 실시간 표시</a:t>
+              <a:t>회로도 이미지 업로드 + 자연어 프롬프트 → Vision 분석 → 검증 결과 실시간 표시</a:t>
             </a:r>
           </a:p>
         </p:txBody>
@@ -29267,7 +29729,7 @@
                   <a:srgbClr val="1B3A6B"/>
                 </a:solidFill>
               </a:rPr>
-              <a:t>1  핀맵 CSV 업로드</a:t>
+              <a:t>1  회로도 이미지 업로드 (Vision 자동 분석)</a:t>
             </a:r>
           </a:p>
         </p:txBody>
@@ -29332,7 +29794,7 @@
           <a:noFill/>
           <a:ln w="15240">
             <a:solidFill>
-              <a:srgbClr val="90B4CC"/>
+              <a:srgbClr val="007A8A"/>
             </a:solidFill>
           </a:ln>
         </p:spPr>
@@ -29366,62 +29828,62 @@
         </p:nvSpPr>
         <p:spPr>
           <a:xfrm>
-            <a:off x="4114800" y="3017520"/>
-            <a:ext cx="548640" cy="256032"/>
-          </a:xfrm>
-          <a:prstGeom prst="rect">
-            <a:avLst/>
-          </a:prstGeom>
-          <a:noFill/>
-        </p:spPr>
-        <p:txBody>
-          <a:bodyPr wrap="square">
-            <a:spAutoFit/>
-          </a:bodyPr>
-          <a:lstStyle/>
-          <a:p>
-            <a:pPr algn="ctr"/>
-            <a:r>
-              <a:rPr sz="1400" b="0" i="0">
+            <a:off x="4069079" y="3017520"/>
+            <a:ext cx="640080" cy="256032"/>
+          </a:xfrm>
+          <a:prstGeom prst="rect">
+            <a:avLst/>
+          </a:prstGeom>
+          <a:noFill/>
+        </p:spPr>
+        <p:txBody>
+          <a:bodyPr wrap="square">
+            <a:spAutoFit/>
+          </a:bodyPr>
+          <a:lstStyle/>
+          <a:p>
+            <a:pPr algn="ctr"/>
+            <a:r>
+              <a:rPr sz="1200" b="1" i="0">
+                <a:solidFill>
+                  <a:srgbClr val="007A8A"/>
+                </a:solidFill>
+              </a:rPr>
+              <a:t>[IMG]</a:t>
+            </a:r>
+          </a:p>
+        </p:txBody>
+      </p:sp>
+      <p:sp>
+        <p:nvSpPr>
+          <p:cNvPr id="40" name="TextBox 39"/>
+          <p:cNvSpPr txBox="1"/>
+          <p:nvPr/>
+        </p:nvSpPr>
+        <p:spPr>
+          <a:xfrm>
+            <a:off x="2304288" y="3264408"/>
+            <a:ext cx="4160520" cy="182880"/>
+          </a:xfrm>
+          <a:prstGeom prst="rect">
+            <a:avLst/>
+          </a:prstGeom>
+          <a:noFill/>
+        </p:spPr>
+        <p:txBody>
+          <a:bodyPr wrap="square">
+            <a:spAutoFit/>
+          </a:bodyPr>
+          <a:lstStyle/>
+          <a:p>
+            <a:pPr algn="ctr"/>
+            <a:r>
+              <a:rPr sz="850" b="0" i="0">
                 <a:solidFill>
                   <a:srgbClr val="718296"/>
                 </a:solidFill>
               </a:rPr>
-              <a:t>[  ]</a:t>
-            </a:r>
-          </a:p>
-        </p:txBody>
-      </p:sp>
-      <p:sp>
-        <p:nvSpPr>
-          <p:cNvPr id="40" name="TextBox 39"/>
-          <p:cNvSpPr txBox="1"/>
-          <p:nvPr/>
-        </p:nvSpPr>
-        <p:spPr>
-          <a:xfrm>
-            <a:off x="2377440" y="3264408"/>
-            <a:ext cx="4023359" cy="182880"/>
-          </a:xfrm>
-          <a:prstGeom prst="rect">
-            <a:avLst/>
-          </a:prstGeom>
-          <a:noFill/>
-        </p:spPr>
-        <p:txBody>
-          <a:bodyPr wrap="square">
-            <a:spAutoFit/>
-          </a:bodyPr>
-          <a:lstStyle/>
-          <a:p>
-            <a:pPr algn="ctr"/>
-            <a:r>
-              <a:rPr sz="850" b="0" i="0">
-                <a:solidFill>
-                  <a:srgbClr val="718296"/>
-                </a:solidFill>
-              </a:rPr>
-              <a:t>CSV 파일을 드래그하거나 클릭하여 업로드</a:t>
+              <a:t>회로도 이미지를 드래그하거나 클릭하여 업로드 (JPEG/PNG)</a:t>
             </a:r>
           </a:p>
         </p:txBody>
@@ -29434,8 +29896,8 @@
         </p:nvSpPr>
         <p:spPr>
           <a:xfrm>
-            <a:off x="2377440" y="3447288"/>
-            <a:ext cx="4023359" cy="182880"/>
+            <a:off x="2304288" y="3447288"/>
+            <a:ext cx="4160520" cy="182880"/>
           </a:xfrm>
           <a:prstGeom prst="rect">
             <a:avLst/>
@@ -29452,10 +29914,10 @@
             <a:r>
               <a:rPr sz="850" b="1" i="0">
                 <a:solidFill>
-                  <a:srgbClr val="107C10"/>
-                </a:solidFill>
-              </a:rPr>
-              <a:t>pinmap_BLDC_v2.csv  (업로드 완료 ✓)</a:t>
+                  <a:srgbClr val="007A8A"/>
+                </a:solidFill>
+              </a:rPr>
+              <a:t>schematic_bldc_v3.png  (업로드 완료 ✓  →  Vision 분석 예정)</a:t>
             </a:r>
           </a:p>
         </p:txBody>
@@ -29477,7 +29939,7 @@
           <a:noFill/>
           <a:ln w="12700">
             <a:solidFill>
-              <a:srgbClr val="107C10"/>
+              <a:srgbClr val="007A8A"/>
             </a:solidFill>
           </a:ln>
         </p:spPr>
@@ -61923,8 +62385,8 @@
                   <a:srgbClr val="1A1A1A"/>
                 </a:solidFill>
               </a:rPr>
-              <a:t>• 회로도 입력
-(CSV + 자연어)</a:t>
+              <a:t>• 회로도 이미지
+(Vision 자동 분석)</a:t>
             </a:r>
           </a:p>
         </p:txBody>
@@ -62104,7 +62566,7 @@
                 </a:solidFill>
               </a:rPr>
               <a:t>모델 : Gemma 4 31B Dense
-(~20GB)</a:t>
+(~20GB, Vision 겸용)</a:t>
             </a:r>
           </a:p>
         </p:txBody>
@@ -62182,7 +62644,7 @@
                 </a:solidFill>
               </a:rPr>
               <a:t>출력 : 검증 완료
-핀 JSON</a:t>
+핀 JSON + Vision 분석</a:t>
             </a:r>
           </a:p>
         </p:txBody>
@@ -69808,7 +70270,7 @@
         <p:spPr>
           <a:xfrm>
             <a:off x="365760" y="2103120"/>
-            <a:ext cx="5303520" cy="594360"/>
+            <a:ext cx="5303520" cy="475488"/>
           </a:xfrm>
           <a:prstGeom prst="rect">
             <a:avLst/>
@@ -69851,27 +70313,27 @@
         <p:spPr>
           <a:xfrm>
             <a:off x="502920" y="2139696"/>
-            <a:ext cx="1280160" cy="274320"/>
-          </a:xfrm>
-          <a:prstGeom prst="rect">
-            <a:avLst/>
-          </a:prstGeom>
-          <a:noFill/>
-        </p:spPr>
-        <p:txBody>
-          <a:bodyPr wrap="square">
-            <a:spAutoFit/>
-          </a:bodyPr>
-          <a:lstStyle/>
-          <a:p>
-            <a:pPr algn="l"/>
-            <a:r>
-              <a:rPr sz="1200" b="1" i="0">
+            <a:ext cx="1463040" cy="274320"/>
+          </a:xfrm>
+          <a:prstGeom prst="rect">
+            <a:avLst/>
+          </a:prstGeom>
+          <a:noFill/>
+        </p:spPr>
+        <p:txBody>
+          <a:bodyPr wrap="square">
+            <a:spAutoFit/>
+          </a:bodyPr>
+          <a:lstStyle/>
+          <a:p>
+            <a:pPr algn="l"/>
+            <a:r>
+              <a:rPr sz="1100" b="1" i="0">
                 <a:solidFill>
                   <a:srgbClr val="007A8A"/>
                 </a:solidFill>
               </a:rPr>
-              <a:t>3계층 규칙엔진</a:t>
+              <a:t>Vision 분석</a:t>
             </a:r>
           </a:p>
         </p:txBody>
@@ -69884,28 +70346,28 @@
         </p:nvSpPr>
         <p:spPr>
           <a:xfrm>
-            <a:off x="1920240" y="2139696"/>
-            <a:ext cx="3566160" cy="502920"/>
-          </a:xfrm>
-          <a:prstGeom prst="rect">
-            <a:avLst/>
-          </a:prstGeom>
-          <a:noFill/>
-        </p:spPr>
-        <p:txBody>
-          <a:bodyPr wrap="square">
-            <a:spAutoFit/>
-          </a:bodyPr>
-          <a:lstStyle/>
-          <a:p>
-            <a:pPr algn="l"/>
-            <a:r>
-              <a:rPr sz="1200" b="0" i="0">
+            <a:off x="2103120" y="2139696"/>
+            <a:ext cx="3383280" cy="411480"/>
+          </a:xfrm>
+          <a:prstGeom prst="rect">
+            <a:avLst/>
+          </a:prstGeom>
+          <a:noFill/>
+        </p:spPr>
+        <p:txBody>
+          <a:bodyPr wrap="square">
+            <a:spAutoFit/>
+          </a:bodyPr>
+          <a:lstStyle/>
+          <a:p>
+            <a:pPr algn="l"/>
+            <a:r>
+              <a:rPr sz="1050" b="0" i="0">
                 <a:solidFill>
                   <a:srgbClr val="1A1A1A"/>
                 </a:solidFill>
               </a:rPr>
-              <a:t>① 인프라 ② 모터논리(상보PWM) ③ 페리페럴(ADC/OPAMP)</a:t>
+              <a:t>Gemma 4 31B Multimodal: 회로도 이미지 → 핀맵 자동 추출 + 초기 분석</a:t>
             </a:r>
           </a:p>
         </p:txBody>
@@ -69918,8 +70380,8 @@
         </p:nvSpPr>
         <p:spPr>
           <a:xfrm>
-            <a:off x="365760" y="2761487"/>
-            <a:ext cx="5303520" cy="594360"/>
+            <a:off x="365760" y="2633472"/>
+            <a:ext cx="5303520" cy="475488"/>
           </a:xfrm>
           <a:prstGeom prst="rect">
             <a:avLst/>
@@ -69961,28 +70423,28 @@
         </p:nvSpPr>
         <p:spPr>
           <a:xfrm>
-            <a:off x="502920" y="2798063"/>
-            <a:ext cx="1280160" cy="274320"/>
-          </a:xfrm>
-          <a:prstGeom prst="rect">
-            <a:avLst/>
-          </a:prstGeom>
-          <a:noFill/>
-        </p:spPr>
-        <p:txBody>
-          <a:bodyPr wrap="square">
-            <a:spAutoFit/>
-          </a:bodyPr>
-          <a:lstStyle/>
-          <a:p>
-            <a:pPr algn="l"/>
-            <a:r>
-              <a:rPr sz="1200" b="1" i="0">
+            <a:off x="502920" y="2670048"/>
+            <a:ext cx="1463040" cy="274320"/>
+          </a:xfrm>
+          <a:prstGeom prst="rect">
+            <a:avLst/>
+          </a:prstGeom>
+          <a:noFill/>
+        </p:spPr>
+        <p:txBody>
+          <a:bodyPr wrap="square">
+            <a:spAutoFit/>
+          </a:bodyPr>
+          <a:lstStyle/>
+          <a:p>
+            <a:pPr algn="l"/>
+            <a:r>
+              <a:rPr sz="1100" b="1" i="0">
                 <a:solidFill>
                   <a:srgbClr val="007A8A"/>
                 </a:solidFill>
               </a:rPr>
-              <a:t>RAG 구성</a:t>
+              <a:t>3계층 규칙엔진</a:t>
             </a:r>
           </a:p>
         </p:txBody>
@@ -69995,28 +70457,28 @@
         </p:nvSpPr>
         <p:spPr>
           <a:xfrm>
-            <a:off x="1920240" y="2798063"/>
-            <a:ext cx="3566160" cy="502920"/>
-          </a:xfrm>
-          <a:prstGeom prst="rect">
-            <a:avLst/>
-          </a:prstGeom>
-          <a:noFill/>
-        </p:spPr>
-        <p:txBody>
-          <a:bodyPr wrap="square">
-            <a:spAutoFit/>
-          </a:bodyPr>
-          <a:lstStyle/>
-          <a:p>
-            <a:pPr algn="l"/>
-            <a:r>
-              <a:rPr sz="1200" b="0" i="0">
+            <a:off x="2103120" y="2670048"/>
+            <a:ext cx="3383280" cy="411480"/>
+          </a:xfrm>
+          <a:prstGeom prst="rect">
+            <a:avLst/>
+          </a:prstGeom>
+          <a:noFill/>
+        </p:spPr>
+        <p:txBody>
+          <a:bodyPr wrap="square">
+            <a:spAutoFit/>
+          </a:bodyPr>
+          <a:lstStyle/>
+          <a:p>
+            <a:pPr algn="l"/>
+            <a:r>
+              <a:rPr sz="1050" b="0" i="0">
                 <a:solidFill>
                   <a:srgbClr val="1A1A1A"/>
                 </a:solidFill>
               </a:rPr>
-              <a:t>PDF + 오픈소스 회로도 → 청킹 → BGE-M3 → Qdrant</a:t>
+              <a:t>① 인프라 ② 모터논리(상보PWM) ③ 페리페럴(ADC/OPAMP)</a:t>
             </a:r>
           </a:p>
         </p:txBody>
@@ -70029,8 +70491,8 @@
         </p:nvSpPr>
         <p:spPr>
           <a:xfrm>
-            <a:off x="365760" y="3419856"/>
-            <a:ext cx="5303520" cy="594360"/>
+            <a:off x="365760" y="3163824"/>
+            <a:ext cx="5303520" cy="475488"/>
           </a:xfrm>
           <a:prstGeom prst="rect">
             <a:avLst/>
@@ -70072,28 +70534,28 @@
         </p:nvSpPr>
         <p:spPr>
           <a:xfrm>
-            <a:off x="502920" y="3456432"/>
-            <a:ext cx="1280160" cy="274320"/>
-          </a:xfrm>
-          <a:prstGeom prst="rect">
-            <a:avLst/>
-          </a:prstGeom>
-          <a:noFill/>
-        </p:spPr>
-        <p:txBody>
-          <a:bodyPr wrap="square">
-            <a:spAutoFit/>
-          </a:bodyPr>
-          <a:lstStyle/>
-          <a:p>
-            <a:pPr algn="l"/>
-            <a:r>
-              <a:rPr sz="1200" b="1" i="0">
+            <a:off x="502920" y="3200400"/>
+            <a:ext cx="1463040" cy="274320"/>
+          </a:xfrm>
+          <a:prstGeom prst="rect">
+            <a:avLst/>
+          </a:prstGeom>
+          <a:noFill/>
+        </p:spPr>
+        <p:txBody>
+          <a:bodyPr wrap="square">
+            <a:spAutoFit/>
+          </a:bodyPr>
+          <a:lstStyle/>
+          <a:p>
+            <a:pPr algn="l"/>
+            <a:r>
+              <a:rPr sz="1100" b="1" i="0">
                 <a:solidFill>
                   <a:srgbClr val="007A8A"/>
                 </a:solidFill>
               </a:rPr>
-              <a:t>LLM 연결</a:t>
+              <a:t>RAG 구성</a:t>
             </a:r>
           </a:p>
         </p:txBody>
@@ -70106,28 +70568,28 @@
         </p:nvSpPr>
         <p:spPr>
           <a:xfrm>
-            <a:off x="1920240" y="3456432"/>
-            <a:ext cx="3566160" cy="502920"/>
-          </a:xfrm>
-          <a:prstGeom prst="rect">
-            <a:avLst/>
-          </a:prstGeom>
-          <a:noFill/>
-        </p:spPr>
-        <p:txBody>
-          <a:bodyPr wrap="square">
-            <a:spAutoFit/>
-          </a:bodyPr>
-          <a:lstStyle/>
-          <a:p>
-            <a:pPr algn="l"/>
-            <a:r>
-              <a:rPr sz="1200" b="0" i="0">
+            <a:off x="2103120" y="3200400"/>
+            <a:ext cx="3383280" cy="411480"/>
+          </a:xfrm>
+          <a:prstGeom prst="rect">
+            <a:avLst/>
+          </a:prstGeom>
+          <a:noFill/>
+        </p:spPr>
+        <p:txBody>
+          <a:bodyPr wrap="square">
+            <a:spAutoFit/>
+          </a:bodyPr>
+          <a:lstStyle/>
+          <a:p>
+            <a:pPr algn="l"/>
+            <a:r>
+              <a:rPr sz="1050" b="0" i="0">
                 <a:solidFill>
                   <a:srgbClr val="1A1A1A"/>
                 </a:solidFill>
               </a:rPr>
-              <a:t>Gemma 4 31B Dense: 자연어 설명 + JSON 구조화 출력</a:t>
+              <a:t>PDF + 오픈소스 회로도 → 청킹 → BGE-M3 → Qdrant (Vision 분석으로 쿼리 보강)</a:t>
             </a:r>
           </a:p>
         </p:txBody>
@@ -70140,8 +70602,8 @@
         </p:nvSpPr>
         <p:spPr>
           <a:xfrm>
-            <a:off x="365760" y="4078224"/>
-            <a:ext cx="5303520" cy="594360"/>
+            <a:off x="365760" y="3694175"/>
+            <a:ext cx="5303520" cy="475488"/>
           </a:xfrm>
           <a:prstGeom prst="rect">
             <a:avLst/>
@@ -70183,27 +70645,138 @@
         </p:nvSpPr>
         <p:spPr>
           <a:xfrm>
-            <a:off x="502920" y="4114800"/>
-            <a:ext cx="1280160" cy="274320"/>
-          </a:xfrm>
-          <a:prstGeom prst="rect">
-            <a:avLst/>
-          </a:prstGeom>
-          <a:noFill/>
-        </p:spPr>
-        <p:txBody>
-          <a:bodyPr wrap="square">
-            <a:spAutoFit/>
-          </a:bodyPr>
-          <a:lstStyle/>
-          <a:p>
-            <a:pPr algn="l"/>
-            <a:r>
-              <a:rPr sz="1200" b="1" i="0">
+            <a:off x="502920" y="3730752"/>
+            <a:ext cx="1463040" cy="274320"/>
+          </a:xfrm>
+          <a:prstGeom prst="rect">
+            <a:avLst/>
+          </a:prstGeom>
+          <a:noFill/>
+        </p:spPr>
+        <p:txBody>
+          <a:bodyPr wrap="square">
+            <a:spAutoFit/>
+          </a:bodyPr>
+          <a:lstStyle/>
+          <a:p>
+            <a:pPr algn="l"/>
+            <a:r>
+              <a:rPr sz="1100" b="1" i="0">
                 <a:solidFill>
                   <a:srgbClr val="007A8A"/>
                 </a:solidFill>
               </a:rPr>
+              <a:t>LLM 연결</a:t>
+            </a:r>
+          </a:p>
+        </p:txBody>
+      </p:sp>
+      <p:sp>
+        <p:nvSpPr>
+          <p:cNvPr id="23" name="TextBox 22"/>
+          <p:cNvSpPr txBox="1"/>
+          <p:nvPr/>
+        </p:nvSpPr>
+        <p:spPr>
+          <a:xfrm>
+            <a:off x="2103120" y="3730752"/>
+            <a:ext cx="3383280" cy="411480"/>
+          </a:xfrm>
+          <a:prstGeom prst="rect">
+            <a:avLst/>
+          </a:prstGeom>
+          <a:noFill/>
+        </p:spPr>
+        <p:txBody>
+          <a:bodyPr wrap="square">
+            <a:spAutoFit/>
+          </a:bodyPr>
+          <a:lstStyle/>
+          <a:p>
+            <a:pPr algn="l"/>
+            <a:r>
+              <a:rPr sz="1050" b="0" i="0">
+                <a:solidFill>
+                  <a:srgbClr val="1A1A1A"/>
+                </a:solidFill>
+              </a:rPr>
+              <a:t>Gemma 4 31B Dense: 자연어 설명 + JSON 구조화 출력 (Vision 분석 컨텍스트 포함)</a:t>
+            </a:r>
+          </a:p>
+        </p:txBody>
+      </p:sp>
+      <p:sp>
+        <p:nvSpPr>
+          <p:cNvPr id="24" name="Rectangle 23"/>
+          <p:cNvSpPr/>
+          <p:nvPr/>
+        </p:nvSpPr>
+        <p:spPr>
+          <a:xfrm>
+            <a:off x="365760" y="4224527"/>
+            <a:ext cx="5303520" cy="475488"/>
+          </a:xfrm>
+          <a:prstGeom prst="rect">
+            <a:avLst/>
+          </a:prstGeom>
+          <a:solidFill>
+            <a:srgbClr val="D0F0F4"/>
+          </a:solidFill>
+          <a:ln>
+            <a:noFill/>
+          </a:ln>
+        </p:spPr>
+        <p:style>
+          <a:lnRef idx="1">
+            <a:schemeClr val="accent1"/>
+          </a:lnRef>
+          <a:fillRef idx="3">
+            <a:schemeClr val="accent1"/>
+          </a:fillRef>
+          <a:effectRef idx="2">
+            <a:schemeClr val="accent1"/>
+          </a:effectRef>
+          <a:fontRef idx="minor">
+            <a:schemeClr val="lt1"/>
+          </a:fontRef>
+        </p:style>
+        <p:txBody>
+          <a:bodyPr rtlCol="0" anchor="ctr"/>
+          <a:lstStyle/>
+          <a:p>
+            <a:pPr algn="ctr"/>
+          </a:p>
+        </p:txBody>
+      </p:sp>
+      <p:sp>
+        <p:nvSpPr>
+          <p:cNvPr id="25" name="TextBox 24"/>
+          <p:cNvSpPr txBox="1"/>
+          <p:nvPr/>
+        </p:nvSpPr>
+        <p:spPr>
+          <a:xfrm>
+            <a:off x="502920" y="4261104"/>
+            <a:ext cx="1463040" cy="274320"/>
+          </a:xfrm>
+          <a:prstGeom prst="rect">
+            <a:avLst/>
+          </a:prstGeom>
+          <a:noFill/>
+        </p:spPr>
+        <p:txBody>
+          <a:bodyPr wrap="square">
+            <a:spAutoFit/>
+          </a:bodyPr>
+          <a:lstStyle/>
+          <a:p>
+            <a:pPr algn="l"/>
+            <a:r>
+              <a:rPr sz="1100" b="1" i="0">
+                <a:solidFill>
+                  <a:srgbClr val="007A8A"/>
+                </a:solidFill>
+              </a:rPr>
               <a:t>UI 구성</a:t>
             </a:r>
           </a:p>
@@ -70211,41 +70784,41 @@
       </p:sp>
       <p:sp>
         <p:nvSpPr>
-          <p:cNvPr id="23" name="TextBox 22"/>
-          <p:cNvSpPr txBox="1"/>
-          <p:nvPr/>
-        </p:nvSpPr>
-        <p:spPr>
-          <a:xfrm>
-            <a:off x="1920240" y="4114800"/>
-            <a:ext cx="3566160" cy="502920"/>
-          </a:xfrm>
-          <a:prstGeom prst="rect">
-            <a:avLst/>
-          </a:prstGeom>
-          <a:noFill/>
-        </p:spPr>
-        <p:txBody>
-          <a:bodyPr wrap="square">
-            <a:spAutoFit/>
-          </a:bodyPr>
-          <a:lstStyle/>
-          <a:p>
-            <a:pPr algn="l"/>
-            <a:r>
-              <a:rPr sz="1200" b="0" i="0">
+          <p:cNvPr id="26" name="TextBox 25"/>
+          <p:cNvSpPr txBox="1"/>
+          <p:nvPr/>
+        </p:nvSpPr>
+        <p:spPr>
+          <a:xfrm>
+            <a:off x="2103120" y="4261104"/>
+            <a:ext cx="3383280" cy="411480"/>
+          </a:xfrm>
+          <a:prstGeom prst="rect">
+            <a:avLst/>
+          </a:prstGeom>
+          <a:noFill/>
+        </p:spPr>
+        <p:txBody>
+          <a:bodyPr wrap="square">
+            <a:spAutoFit/>
+          </a:bodyPr>
+          <a:lstStyle/>
+          <a:p>
+            <a:pPr algn="l"/>
+            <a:r>
+              <a:rPr sz="1050" b="0" i="0">
                 <a:solidFill>
                   <a:srgbClr val="1A1A1A"/>
                 </a:solidFill>
               </a:rPr>
-              <a:t>Streamlit: 회로도 업로드 → 검증 진행 → 리포트 표시</a:t>
-            </a:r>
-          </a:p>
-        </p:txBody>
-      </p:sp>
-      <p:sp>
-        <p:nvSpPr>
-          <p:cNvPr id="24" name="TextBox 23"/>
+              <a:t>Streamlit: 이미지 업로드 → Vision 분석 → 검증 리포트 + vision_analysis 표시</a:t>
+            </a:r>
+          </a:p>
+        </p:txBody>
+      </p:sp>
+      <p:sp>
+        <p:nvSpPr>
+          <p:cNvPr id="27" name="TextBox 26"/>
           <p:cNvSpPr txBox="1"/>
           <p:nvPr/>
         </p:nvSpPr>
@@ -70279,7 +70852,7 @@
       </p:sp>
       <p:sp>
         <p:nvSpPr>
-          <p:cNvPr id="25" name="Rectangle 24"/>
+          <p:cNvPr id="28" name="Rectangle 27"/>
           <p:cNvSpPr/>
           <p:nvPr/>
         </p:nvSpPr>
@@ -70322,7 +70895,7 @@
       </p:sp>
       <p:sp>
         <p:nvSpPr>
-          <p:cNvPr id="26" name="TextBox 25"/>
+          <p:cNvPr id="29" name="TextBox 28"/>
           <p:cNvSpPr txBox="1"/>
           <p:nvPr/>
         </p:nvSpPr>
@@ -70356,7 +70929,7 @@
       </p:sp>
       <p:sp>
         <p:nvSpPr>
-          <p:cNvPr id="27" name="TextBox 26"/>
+          <p:cNvPr id="30" name="TextBox 29"/>
           <p:cNvSpPr txBox="1"/>
           <p:nvPr/>
         </p:nvSpPr>
@@ -70390,7 +70963,7 @@
       </p:sp>
       <p:sp>
         <p:nvSpPr>
-          <p:cNvPr id="28" name="TextBox 27"/>
+          <p:cNvPr id="31" name="TextBox 30"/>
           <p:cNvSpPr txBox="1"/>
           <p:nvPr/>
         </p:nvSpPr>
@@ -70424,7 +70997,7 @@
       </p:sp>
       <p:sp>
         <p:nvSpPr>
-          <p:cNvPr id="29" name="Rectangle 28"/>
+          <p:cNvPr id="32" name="Rectangle 31"/>
           <p:cNvSpPr/>
           <p:nvPr/>
         </p:nvSpPr>
@@ -70467,7 +71040,7 @@
       </p:sp>
       <p:sp>
         <p:nvSpPr>
-          <p:cNvPr id="30" name="TextBox 29"/>
+          <p:cNvPr id="33" name="TextBox 32"/>
           <p:cNvSpPr txBox="1"/>
           <p:nvPr/>
         </p:nvSpPr>
@@ -70501,7 +71074,7 @@
       </p:sp>
       <p:sp>
         <p:nvSpPr>
-          <p:cNvPr id="31" name="TextBox 30"/>
+          <p:cNvPr id="34" name="TextBox 33"/>
           <p:cNvSpPr txBox="1"/>
           <p:nvPr/>
         </p:nvSpPr>
@@ -70535,7 +71108,7 @@
       </p:sp>
       <p:sp>
         <p:nvSpPr>
-          <p:cNvPr id="32" name="TextBox 31"/>
+          <p:cNvPr id="35" name="TextBox 34"/>
           <p:cNvSpPr txBox="1"/>
           <p:nvPr/>
         </p:nvSpPr>
@@ -70569,7 +71142,7 @@
       </p:sp>
       <p:sp>
         <p:nvSpPr>
-          <p:cNvPr id="33" name="Rectangle 32"/>
+          <p:cNvPr id="36" name="Rectangle 35"/>
           <p:cNvSpPr/>
           <p:nvPr/>
         </p:nvSpPr>
@@ -70612,7 +71185,7 @@
       </p:sp>
       <p:sp>
         <p:nvSpPr>
-          <p:cNvPr id="34" name="TextBox 33"/>
+          <p:cNvPr id="37" name="TextBox 36"/>
           <p:cNvSpPr txBox="1"/>
           <p:nvPr/>
         </p:nvSpPr>
@@ -70646,7 +71219,7 @@
       </p:sp>
       <p:sp>
         <p:nvSpPr>
-          <p:cNvPr id="35" name="TextBox 34"/>
+          <p:cNvPr id="38" name="TextBox 37"/>
           <p:cNvSpPr txBox="1"/>
           <p:nvPr/>
         </p:nvSpPr>
@@ -70680,7 +71253,7 @@
       </p:sp>
       <p:sp>
         <p:nvSpPr>
-          <p:cNvPr id="36" name="TextBox 35"/>
+          <p:cNvPr id="39" name="TextBox 38"/>
           <p:cNvSpPr txBox="1"/>
           <p:nvPr/>
         </p:nvSpPr>
@@ -70714,7 +71287,7 @@
       </p:sp>
       <p:sp>
         <p:nvSpPr>
-          <p:cNvPr id="37" name="Rectangle 36"/>
+          <p:cNvPr id="40" name="Rectangle 39"/>
           <p:cNvSpPr/>
           <p:nvPr/>
         </p:nvSpPr>
@@ -70757,7 +71330,7 @@
       </p:sp>
       <p:sp>
         <p:nvSpPr>
-          <p:cNvPr id="38" name="TextBox 37"/>
+          <p:cNvPr id="41" name="TextBox 40"/>
           <p:cNvSpPr txBox="1"/>
           <p:nvPr/>
         </p:nvSpPr>
@@ -70791,7 +71364,7 @@
       </p:sp>
       <p:sp>
         <p:nvSpPr>
-          <p:cNvPr id="39" name="TextBox 38"/>
+          <p:cNvPr id="42" name="TextBox 41"/>
           <p:cNvSpPr txBox="1"/>
           <p:nvPr/>
         </p:nvSpPr>
@@ -70825,7 +71398,7 @@
       </p:sp>
       <p:sp>
         <p:nvSpPr>
-          <p:cNvPr id="40" name="TextBox 39"/>
+          <p:cNvPr id="43" name="TextBox 42"/>
           <p:cNvSpPr txBox="1"/>
           <p:nvPr/>
         </p:nvSpPr>
@@ -70859,7 +71432,7 @@
       </p:sp>
       <p:sp>
         <p:nvSpPr>
-          <p:cNvPr id="41" name="Rectangle 40"/>
+          <p:cNvPr id="44" name="Rectangle 43"/>
           <p:cNvSpPr/>
           <p:nvPr/>
         </p:nvSpPr>
@@ -70902,7 +71475,7 @@
       </p:sp>
       <p:sp>
         <p:nvSpPr>
-          <p:cNvPr id="42" name="TextBox 41"/>
+          <p:cNvPr id="45" name="TextBox 44"/>
           <p:cNvSpPr txBox="1"/>
           <p:nvPr/>
         </p:nvSpPr>
@@ -70936,7 +71509,7 @@
       </p:sp>
       <p:sp>
         <p:nvSpPr>
-          <p:cNvPr id="43" name="TextBox 42"/>
+          <p:cNvPr id="46" name="TextBox 45"/>
           <p:cNvSpPr txBox="1"/>
           <p:nvPr/>
         </p:nvSpPr>
@@ -70970,7 +71543,7 @@
       </p:sp>
       <p:sp>
         <p:nvSpPr>
-          <p:cNvPr id="44" name="TextBox 43"/>
+          <p:cNvPr id="47" name="TextBox 46"/>
           <p:cNvSpPr txBox="1"/>
           <p:nvPr/>
         </p:nvSpPr>
@@ -71004,7 +71577,7 @@
       </p:sp>
       <p:sp>
         <p:nvSpPr>
-          <p:cNvPr id="45" name="Rectangle 44"/>
+          <p:cNvPr id="48" name="Rectangle 47"/>
           <p:cNvSpPr/>
           <p:nvPr/>
         </p:nvSpPr>
@@ -71047,7 +71620,7 @@
       </p:sp>
       <p:sp>
         <p:nvSpPr>
-          <p:cNvPr id="46" name="TextBox 45"/>
+          <p:cNvPr id="49" name="TextBox 48"/>
           <p:cNvSpPr txBox="1"/>
           <p:nvPr/>
         </p:nvSpPr>
@@ -71081,7 +71654,7 @@
       </p:sp>
       <p:sp>
         <p:nvSpPr>
-          <p:cNvPr id="47" name="TextBox 46"/>
+          <p:cNvPr id="50" name="TextBox 49"/>
           <p:cNvSpPr txBox="1"/>
           <p:nvPr/>
         </p:nvSpPr>
@@ -71115,7 +71688,7 @@
       </p:sp>
       <p:sp>
         <p:nvSpPr>
-          <p:cNvPr id="48" name="TextBox 47"/>
+          <p:cNvPr id="51" name="TextBox 50"/>
           <p:cNvSpPr txBox="1"/>
           <p:nvPr/>
         </p:nvSpPr>
@@ -71149,7 +71722,7 @@
       </p:sp>
       <p:sp>
         <p:nvSpPr>
-          <p:cNvPr id="49" name="Rectangle 48"/>
+          <p:cNvPr id="52" name="Rectangle 51"/>
           <p:cNvSpPr/>
           <p:nvPr/>
         </p:nvSpPr>
@@ -71192,7 +71765,7 @@
       </p:sp>
       <p:sp>
         <p:nvSpPr>
-          <p:cNvPr id="50" name="TextBox 49"/>
+          <p:cNvPr id="53" name="TextBox 52"/>
           <p:cNvSpPr txBox="1"/>
           <p:nvPr/>
         </p:nvSpPr>

</xml_diff>